<commit_message>
Cdiscount Mobile : slides recentrées sur les forfaits
Co-Authored-By: Claude Opus 5.5 <noreply@anthropic.com>
Claude-Session: https://claude.ai/code/session_01BmxtdWjbeRUyPx9e1qVLbT
</commit_message>
<xml_diff>
--- a/rapports/septembre/Cdiscount_Mobile_sept2026.pptx
+++ b/rapports/septembre/Cdiscount_Mobile_sept2026.pptx
@@ -5283,22 +5283,22 @@
               </a:spcAft>
             </a:pPr>
             <a:r>
+              <a:rPr sz="2000" b="1" i="0">
+                <a:solidFill>
+                  <a:srgbClr val="EE6A2C"/>
+                </a:solidFill>
+                <a:latin typeface="Arial"/>
+              </a:rPr>
+              <a:t>forfait mobile</a:t>
+            </a:r>
+            <a:r>
               <a:rPr sz="1800" b="1" i="0">
                 <a:solidFill>
-                  <a:srgbClr val="EE6A2C"/>
-                </a:solidFill>
-                <a:latin typeface="Arial"/>
-              </a:rPr>
-              <a:t>iPhone 17 Pro</a:t>
-            </a:r>
-            <a:r>
-              <a:rPr sz="1600" b="1" i="0">
-                <a:solidFill>
                   <a:srgbClr val="111111"/>
                 </a:solidFill>
                 <a:latin typeface="Arial"/>
               </a:rPr>
-              <a:t>   Galaxy S26</a:t>
+              <a:t>   sans engagement</a:t>
             </a:r>
           </a:p>
           <a:p>
@@ -5308,22 +5308,22 @@
               </a:spcAft>
             </a:pPr>
             <a:r>
+              <a:rPr sz="1600" b="1" i="0">
+                <a:solidFill>
+                  <a:srgbClr val="555B66"/>
+                </a:solidFill>
+                <a:latin typeface="Arial"/>
+              </a:rPr>
+              <a:t>40 Go</a:t>
+            </a:r>
+            <a:r>
               <a:rPr sz="1500" b="1" i="0">
                 <a:solidFill>
-                  <a:srgbClr val="555B66"/>
-                </a:solidFill>
-                <a:latin typeface="Arial"/>
-              </a:rPr>
-              <a:t>forfait mobile</a:t>
-            </a:r>
-            <a:r>
-              <a:rPr sz="1400" b="1" i="0">
-                <a:solidFill>
                   <a:srgbClr val="111111"/>
                 </a:solidFill>
                 <a:latin typeface="Arial"/>
               </a:rPr>
-              <a:t>   eSIM</a:t>
+              <a:t>   150 Go</a:t>
             </a:r>
           </a:p>
           <a:p>
@@ -5339,7 +5339,7 @@
                 </a:solidFill>
                 <a:latin typeface="Arial"/>
               </a:rPr>
-              <a:t>reconditionné</a:t>
+              <a:t>4G &amp; 5G</a:t>
             </a:r>
             <a:r>
               <a:rPr sz="1200" b="0" i="0">
@@ -5348,7 +5348,7 @@
                 </a:solidFill>
                 <a:latin typeface="Arial"/>
               </a:rPr>
-              <a:t>   Pixel 10</a:t>
+              <a:t>   eSIM</a:t>
             </a:r>
           </a:p>
           <a:p>
@@ -5364,7 +5364,7 @@
                 </a:solidFill>
                 <a:latin typeface="Arial"/>
               </a:rPr>
-              <a:t>Redmi Note 15 Pro</a:t>
+              <a:t>meilleur prix</a:t>
             </a:r>
             <a:r>
               <a:rPr sz="1100" b="1" i="0">
@@ -5373,7 +5373,7 @@
                 </a:solidFill>
                 <a:latin typeface="Arial"/>
               </a:rPr>
-              <a:t>   256 Go</a:t>
+              <a:t>   data</a:t>
             </a:r>
           </a:p>
           <a:p>
@@ -5398,16 +5398,7 @@
                 </a:solidFill>
                 <a:latin typeface="Arial"/>
               </a:rPr>
-              <a:t>   promotion</a:t>
-            </a:r>
-            <a:r>
-              <a:rPr sz="1100" b="1" i="0">
-                <a:solidFill>
-                  <a:srgbClr val="EE6A2C"/>
-                </a:solidFill>
-                <a:latin typeface="Arial"/>
-              </a:rPr>
-              <a:t>   fiabilité</a:t>
+              <a:t>   changement d'opérateur</a:t>
             </a:r>
           </a:p>
           <a:p>
@@ -5423,7 +5414,7 @@
                 </a:solidFill>
                 <a:latin typeface="Arial"/>
               </a:rPr>
-              <a:t>Honor 600</a:t>
+              <a:t>promotion</a:t>
             </a:r>
             <a:r>
               <a:rPr sz="1100" b="0" i="0">
@@ -5616,470 +5607,14 @@
                 </a:solidFill>
                 <a:latin typeface="Arial"/>
               </a:rPr>
-              <a:t>Montre-moi les smartphones Android 256 Go sous 500 €</a:t>
-            </a:r>
-          </a:p>
-        </p:txBody>
-      </p:sp>
-      <p:sp>
-        <p:nvSpPr>
-          <p:cNvPr id="65" name="Rectangle 64"/>
-          <p:cNvSpPr/>
-          <p:nvPr/>
-        </p:nvSpPr>
-        <p:spPr>
-          <a:xfrm>
-            <a:off x="4437888" y="4632960"/>
-            <a:ext cx="2913888" cy="304800"/>
-          </a:xfrm>
-          <a:prstGeom prst="rect">
-            <a:avLst/>
-          </a:prstGeom>
-          <a:solidFill>
-            <a:srgbClr val="F1EFEA"/>
-          </a:solidFill>
-          <a:ln>
-            <a:noFill/>
-          </a:ln>
-          <a:effectLst/>
-        </p:spPr>
-        <p:style>
-          <a:lnRef idx="1">
-            <a:schemeClr val="accent1"/>
-          </a:lnRef>
-          <a:fillRef idx="3">
-            <a:schemeClr val="accent1"/>
-          </a:fillRef>
-          <a:effectRef idx="2">
-            <a:schemeClr val="accent1"/>
-          </a:effectRef>
-          <a:fontRef idx="minor">
-            <a:schemeClr val="lt1"/>
-          </a:fontRef>
-        </p:style>
-        <p:txBody>
-          <a:bodyPr rtlCol="0" anchor="ctr"/>
-          <a:lstStyle/>
-          <a:p>
-            <a:pPr algn="ctr"/>
-          </a:p>
-        </p:txBody>
-      </p:sp>
-      <p:sp>
-        <p:nvSpPr>
-          <p:cNvPr id="66" name="TextBox 65"/>
-          <p:cNvSpPr txBox="1"/>
-          <p:nvPr/>
-        </p:nvSpPr>
-        <p:spPr>
-          <a:xfrm>
-            <a:off x="4559808" y="4632960"/>
-            <a:ext cx="182880" cy="304800"/>
-          </a:xfrm>
-          <a:prstGeom prst="rect">
-            <a:avLst/>
-          </a:prstGeom>
-          <a:noFill/>
-        </p:spPr>
-        <p:txBody>
-          <a:bodyPr wrap="square" anchor="ctr" lIns="0" rIns="0" tIns="0" bIns="0">
-            <a:spAutoFit/>
-          </a:bodyPr>
-          <a:lstStyle/>
-          <a:p>
-            <a:pPr algn="l"/>
-            <a:r>
-              <a:rPr sz="900" b="0" i="0">
-                <a:solidFill>
-                  <a:srgbClr val="555B66"/>
-                </a:solidFill>
-                <a:latin typeface="Arial"/>
-              </a:rPr>
-              <a:t>🔍</a:t>
-            </a:r>
-          </a:p>
-        </p:txBody>
-      </p:sp>
-      <p:sp>
-        <p:nvSpPr>
-          <p:cNvPr id="67" name="TextBox 66"/>
-          <p:cNvSpPr txBox="1"/>
-          <p:nvPr/>
-        </p:nvSpPr>
-        <p:spPr>
-          <a:xfrm>
-            <a:off x="4791456" y="4632960"/>
-            <a:ext cx="2499360" cy="304800"/>
-          </a:xfrm>
-          <a:prstGeom prst="rect">
-            <a:avLst/>
-          </a:prstGeom>
-          <a:noFill/>
-        </p:spPr>
-        <p:txBody>
-          <a:bodyPr wrap="square" anchor="ctr" lIns="0" rIns="0" tIns="0" bIns="0">
-            <a:spAutoFit/>
-          </a:bodyPr>
-          <a:lstStyle/>
-          <a:p>
-            <a:pPr algn="l"/>
-            <a:r>
-              <a:rPr sz="900" b="0" i="0">
-                <a:solidFill>
-                  <a:srgbClr val="111111"/>
-                </a:solidFill>
-                <a:latin typeface="Arial"/>
-              </a:rPr>
-              <a:t>Je recherche un smartphone microSD pour la photo</a:t>
-            </a:r>
-          </a:p>
-        </p:txBody>
-      </p:sp>
-      <p:sp>
-        <p:nvSpPr>
-          <p:cNvPr id="68" name="Rectangle 67"/>
-          <p:cNvSpPr/>
-          <p:nvPr/>
-        </p:nvSpPr>
-        <p:spPr>
-          <a:xfrm>
-            <a:off x="4437888" y="4998720"/>
-            <a:ext cx="2913888" cy="304800"/>
-          </a:xfrm>
-          <a:prstGeom prst="rect">
-            <a:avLst/>
-          </a:prstGeom>
-          <a:solidFill>
-            <a:srgbClr val="F1EFEA"/>
-          </a:solidFill>
-          <a:ln>
-            <a:noFill/>
-          </a:ln>
-          <a:effectLst/>
-        </p:spPr>
-        <p:style>
-          <a:lnRef idx="1">
-            <a:schemeClr val="accent1"/>
-          </a:lnRef>
-          <a:fillRef idx="3">
-            <a:schemeClr val="accent1"/>
-          </a:fillRef>
-          <a:effectRef idx="2">
-            <a:schemeClr val="accent1"/>
-          </a:effectRef>
-          <a:fontRef idx="minor">
-            <a:schemeClr val="lt1"/>
-          </a:fontRef>
-        </p:style>
-        <p:txBody>
-          <a:bodyPr rtlCol="0" anchor="ctr"/>
-          <a:lstStyle/>
-          <a:p>
-            <a:pPr algn="ctr"/>
-          </a:p>
-        </p:txBody>
-      </p:sp>
-      <p:sp>
-        <p:nvSpPr>
-          <p:cNvPr id="69" name="TextBox 68"/>
-          <p:cNvSpPr txBox="1"/>
-          <p:nvPr/>
-        </p:nvSpPr>
-        <p:spPr>
-          <a:xfrm>
-            <a:off x="4559808" y="4998720"/>
-            <a:ext cx="182880" cy="304800"/>
-          </a:xfrm>
-          <a:prstGeom prst="rect">
-            <a:avLst/>
-          </a:prstGeom>
-          <a:noFill/>
-        </p:spPr>
-        <p:txBody>
-          <a:bodyPr wrap="square" anchor="ctr" lIns="0" rIns="0" tIns="0" bIns="0">
-            <a:spAutoFit/>
-          </a:bodyPr>
-          <a:lstStyle/>
-          <a:p>
-            <a:pPr algn="l"/>
-            <a:r>
-              <a:rPr sz="900" b="0" i="0">
-                <a:solidFill>
-                  <a:srgbClr val="555B66"/>
-                </a:solidFill>
-                <a:latin typeface="Arial"/>
-              </a:rPr>
-              <a:t>🔍</a:t>
-            </a:r>
-          </a:p>
-        </p:txBody>
-      </p:sp>
-      <p:sp>
-        <p:nvSpPr>
-          <p:cNvPr id="70" name="TextBox 69"/>
-          <p:cNvSpPr txBox="1"/>
-          <p:nvPr/>
-        </p:nvSpPr>
-        <p:spPr>
-          <a:xfrm>
-            <a:off x="4791456" y="4998720"/>
-            <a:ext cx="2499360" cy="304800"/>
-          </a:xfrm>
-          <a:prstGeom prst="rect">
-            <a:avLst/>
-          </a:prstGeom>
-          <a:noFill/>
-        </p:spPr>
-        <p:txBody>
-          <a:bodyPr wrap="square" anchor="ctr" lIns="0" rIns="0" tIns="0" bIns="0">
-            <a:spAutoFit/>
-          </a:bodyPr>
-          <a:lstStyle/>
-          <a:p>
-            <a:pPr algn="l"/>
-            <a:r>
-              <a:rPr sz="900" b="0" i="0">
-                <a:solidFill>
-                  <a:srgbClr val="111111"/>
-                </a:solidFill>
-                <a:latin typeface="Arial"/>
-              </a:rPr>
-              <a:t>Comment je sais si un iPhone 15 reconditionné est fiable ?</a:t>
-            </a:r>
-          </a:p>
-        </p:txBody>
-      </p:sp>
-      <p:sp>
-        <p:nvSpPr>
-          <p:cNvPr id="71" name="Rectangle 70"/>
-          <p:cNvSpPr/>
-          <p:nvPr/>
-        </p:nvSpPr>
-        <p:spPr>
-          <a:xfrm>
-            <a:off x="4437888" y="5364480"/>
-            <a:ext cx="2913888" cy="304800"/>
-          </a:xfrm>
-          <a:prstGeom prst="rect">
-            <a:avLst/>
-          </a:prstGeom>
-          <a:solidFill>
-            <a:srgbClr val="F1EFEA"/>
-          </a:solidFill>
-          <a:ln>
-            <a:noFill/>
-          </a:ln>
-          <a:effectLst/>
-        </p:spPr>
-        <p:style>
-          <a:lnRef idx="1">
-            <a:schemeClr val="accent1"/>
-          </a:lnRef>
-          <a:fillRef idx="3">
-            <a:schemeClr val="accent1"/>
-          </a:fillRef>
-          <a:effectRef idx="2">
-            <a:schemeClr val="accent1"/>
-          </a:effectRef>
-          <a:fontRef idx="minor">
-            <a:schemeClr val="lt1"/>
-          </a:fontRef>
-        </p:style>
-        <p:txBody>
-          <a:bodyPr rtlCol="0" anchor="ctr"/>
-          <a:lstStyle/>
-          <a:p>
-            <a:pPr algn="ctr"/>
-          </a:p>
-        </p:txBody>
-      </p:sp>
-      <p:sp>
-        <p:nvSpPr>
-          <p:cNvPr id="72" name="TextBox 71"/>
-          <p:cNvSpPr txBox="1"/>
-          <p:nvPr/>
-        </p:nvSpPr>
-        <p:spPr>
-          <a:xfrm>
-            <a:off x="4559808" y="5364480"/>
-            <a:ext cx="182880" cy="304800"/>
-          </a:xfrm>
-          <a:prstGeom prst="rect">
-            <a:avLst/>
-          </a:prstGeom>
-          <a:noFill/>
-        </p:spPr>
-        <p:txBody>
-          <a:bodyPr wrap="square" anchor="ctr" lIns="0" rIns="0" tIns="0" bIns="0">
-            <a:spAutoFit/>
-          </a:bodyPr>
-          <a:lstStyle/>
-          <a:p>
-            <a:pPr algn="l"/>
-            <a:r>
-              <a:rPr sz="900" b="0" i="0">
-                <a:solidFill>
-                  <a:srgbClr val="555B66"/>
-                </a:solidFill>
-                <a:latin typeface="Arial"/>
-              </a:rPr>
-              <a:t>🔍</a:t>
-            </a:r>
-          </a:p>
-        </p:txBody>
-      </p:sp>
-      <p:sp>
-        <p:nvSpPr>
-          <p:cNvPr id="73" name="TextBox 72"/>
-          <p:cNvSpPr txBox="1"/>
-          <p:nvPr/>
-        </p:nvSpPr>
-        <p:spPr>
-          <a:xfrm>
-            <a:off x="4791456" y="5364480"/>
-            <a:ext cx="2499360" cy="304800"/>
-          </a:xfrm>
-          <a:prstGeom prst="rect">
-            <a:avLst/>
-          </a:prstGeom>
-          <a:noFill/>
-        </p:spPr>
-        <p:txBody>
-          <a:bodyPr wrap="square" anchor="ctr" lIns="0" rIns="0" tIns="0" bIns="0">
-            <a:spAutoFit/>
-          </a:bodyPr>
-          <a:lstStyle/>
-          <a:p>
-            <a:pPr algn="l"/>
-            <a:r>
-              <a:rPr sz="900" b="0" i="0">
-                <a:solidFill>
-                  <a:srgbClr val="111111"/>
-                </a:solidFill>
-                <a:latin typeface="Arial"/>
-              </a:rPr>
-              <a:t>Les Honor vendus en Europe ont-ils bien les services Google ?</a:t>
-            </a:r>
-          </a:p>
-        </p:txBody>
-      </p:sp>
-      <p:sp>
-        <p:nvSpPr>
-          <p:cNvPr id="74" name="Rectangle 73"/>
-          <p:cNvSpPr/>
-          <p:nvPr/>
-        </p:nvSpPr>
-        <p:spPr>
-          <a:xfrm>
-            <a:off x="4437888" y="5730240"/>
-            <a:ext cx="2913888" cy="304800"/>
-          </a:xfrm>
-          <a:prstGeom prst="rect">
-            <a:avLst/>
-          </a:prstGeom>
-          <a:solidFill>
-            <a:srgbClr val="F1EFEA"/>
-          </a:solidFill>
-          <a:ln>
-            <a:noFill/>
-          </a:ln>
-          <a:effectLst/>
-        </p:spPr>
-        <p:style>
-          <a:lnRef idx="1">
-            <a:schemeClr val="accent1"/>
-          </a:lnRef>
-          <a:fillRef idx="3">
-            <a:schemeClr val="accent1"/>
-          </a:fillRef>
-          <a:effectRef idx="2">
-            <a:schemeClr val="accent1"/>
-          </a:effectRef>
-          <a:fontRef idx="minor">
-            <a:schemeClr val="lt1"/>
-          </a:fontRef>
-        </p:style>
-        <p:txBody>
-          <a:bodyPr rtlCol="0" anchor="ctr"/>
-          <a:lstStyle/>
-          <a:p>
-            <a:pPr algn="ctr"/>
-          </a:p>
-        </p:txBody>
-      </p:sp>
-      <p:sp>
-        <p:nvSpPr>
-          <p:cNvPr id="75" name="TextBox 74"/>
-          <p:cNvSpPr txBox="1"/>
-          <p:nvPr/>
-        </p:nvSpPr>
-        <p:spPr>
-          <a:xfrm>
-            <a:off x="4559808" y="5730240"/>
-            <a:ext cx="182880" cy="304800"/>
-          </a:xfrm>
-          <a:prstGeom prst="rect">
-            <a:avLst/>
-          </a:prstGeom>
-          <a:noFill/>
-        </p:spPr>
-        <p:txBody>
-          <a:bodyPr wrap="square" anchor="ctr" lIns="0" rIns="0" tIns="0" bIns="0">
-            <a:spAutoFit/>
-          </a:bodyPr>
-          <a:lstStyle/>
-          <a:p>
-            <a:pPr algn="l"/>
-            <a:r>
-              <a:rPr sz="900" b="0" i="0">
-                <a:solidFill>
-                  <a:srgbClr val="555B66"/>
-                </a:solidFill>
-                <a:latin typeface="Arial"/>
-              </a:rPr>
-              <a:t>🔍</a:t>
-            </a:r>
-          </a:p>
-        </p:txBody>
-      </p:sp>
-      <p:sp>
-        <p:nvSpPr>
-          <p:cNvPr id="76" name="TextBox 75"/>
-          <p:cNvSpPr txBox="1"/>
-          <p:nvPr/>
-        </p:nvSpPr>
-        <p:spPr>
-          <a:xfrm>
-            <a:off x="4791456" y="5730240"/>
-            <a:ext cx="2499360" cy="304800"/>
-          </a:xfrm>
-          <a:prstGeom prst="rect">
-            <a:avLst/>
-          </a:prstGeom>
-          <a:noFill/>
-        </p:spPr>
-        <p:txBody>
-          <a:bodyPr wrap="square" anchor="ctr" lIns="0" rIns="0" tIns="0" bIns="0">
-            <a:spAutoFit/>
-          </a:bodyPr>
-          <a:lstStyle/>
-          <a:p>
-            <a:pPr algn="l"/>
-            <a:r>
-              <a:rPr sz="900" b="0" i="0">
-                <a:solidFill>
-                  <a:srgbClr val="111111"/>
-                </a:solidFill>
-                <a:latin typeface="Arial"/>
-              </a:rPr>
-              <a:t>Ça vaut le coup de changer de smartphone juste pour WhatsApp ?</a:t>
-            </a:r>
-          </a:p>
-        </p:txBody>
-      </p:sp>
-      <p:sp>
-        <p:nvSpPr>
-          <p:cNvPr id="77" name="TextBox 76"/>
+              <a:t>À compléter : le rapport d'insights porte surtout sur les smartphones, pas sur les forfaits</a:t>
+            </a:r>
+          </a:p>
+        </p:txBody>
+      </p:sp>
+      <p:sp>
+        <p:nvSpPr>
+          <p:cNvPr id="65" name="TextBox 64"/>
           <p:cNvSpPr txBox="1"/>
           <p:nvPr/>
         </p:nvSpPr>
@@ -6114,7 +5649,7 @@
       </p:sp>
       <p:sp>
         <p:nvSpPr>
-          <p:cNvPr id="78" name="TextBox 77"/>
+          <p:cNvPr id="66" name="TextBox 65"/>
           <p:cNvSpPr txBox="1"/>
           <p:nvPr/>
         </p:nvSpPr>
@@ -6149,7 +5684,7 @@
       </p:sp>
       <p:sp>
         <p:nvSpPr>
-          <p:cNvPr id="79" name="TextBox 78"/>
+          <p:cNvPr id="67" name="TextBox 66"/>
           <p:cNvSpPr txBox="1"/>
           <p:nvPr/>
         </p:nvSpPr>
@@ -6184,7 +5719,7 @@
       </p:sp>
       <p:sp>
         <p:nvSpPr>
-          <p:cNvPr id="80" name="Rectangle 79"/>
+          <p:cNvPr id="68" name="Rectangle 67"/>
           <p:cNvSpPr/>
           <p:nvPr/>
         </p:nvSpPr>
@@ -6228,7 +5763,7 @@
       </p:sp>
       <p:sp>
         <p:nvSpPr>
-          <p:cNvPr id="81" name="TextBox 80"/>
+          <p:cNvPr id="69" name="TextBox 68"/>
           <p:cNvSpPr txBox="1"/>
           <p:nvPr/>
         </p:nvSpPr>
@@ -6263,7 +5798,7 @@
       </p:sp>
       <p:sp>
         <p:nvSpPr>
-          <p:cNvPr id="82" name="Rectangle 81"/>
+          <p:cNvPr id="70" name="Rectangle 69"/>
           <p:cNvSpPr/>
           <p:nvPr/>
         </p:nvSpPr>
@@ -6307,7 +5842,7 @@
       </p:sp>
       <p:sp>
         <p:nvSpPr>
-          <p:cNvPr id="83" name="TextBox 82"/>
+          <p:cNvPr id="71" name="TextBox 70"/>
           <p:cNvSpPr txBox="1"/>
           <p:nvPr/>
         </p:nvSpPr>
@@ -6342,7 +5877,7 @@
       </p:sp>
       <p:sp>
         <p:nvSpPr>
-          <p:cNvPr id="84" name="Rectangle 83"/>
+          <p:cNvPr id="72" name="Rectangle 71"/>
           <p:cNvSpPr/>
           <p:nvPr/>
         </p:nvSpPr>
@@ -6386,7 +5921,7 @@
       </p:sp>
       <p:sp>
         <p:nvSpPr>
-          <p:cNvPr id="85" name="TextBox 84"/>
+          <p:cNvPr id="73" name="TextBox 72"/>
           <p:cNvSpPr txBox="1"/>
           <p:nvPr/>
         </p:nvSpPr>
@@ -6421,7 +5956,7 @@
       </p:sp>
       <p:sp>
         <p:nvSpPr>
-          <p:cNvPr id="86" name="Rectangle 85"/>
+          <p:cNvPr id="74" name="Rectangle 73"/>
           <p:cNvSpPr/>
           <p:nvPr/>
         </p:nvSpPr>
@@ -6465,7 +6000,7 @@
       </p:sp>
       <p:sp>
         <p:nvSpPr>
-          <p:cNvPr id="87" name="TextBox 86"/>
+          <p:cNvPr id="75" name="TextBox 74"/>
           <p:cNvSpPr txBox="1"/>
           <p:nvPr/>
         </p:nvSpPr>
@@ -6500,7 +6035,7 @@
       </p:sp>
       <p:sp>
         <p:nvSpPr>
-          <p:cNvPr id="88" name="Rectangle 87"/>
+          <p:cNvPr id="76" name="Rectangle 75"/>
           <p:cNvSpPr/>
           <p:nvPr/>
         </p:nvSpPr>
@@ -6544,7 +6079,7 @@
       </p:sp>
       <p:sp>
         <p:nvSpPr>
-          <p:cNvPr id="89" name="TextBox 88"/>
+          <p:cNvPr id="77" name="TextBox 76"/>
           <p:cNvSpPr txBox="1"/>
           <p:nvPr/>
         </p:nvSpPr>
@@ -6579,7 +6114,7 @@
       </p:sp>
       <p:sp>
         <p:nvSpPr>
-          <p:cNvPr id="90" name="Rectangle 89"/>
+          <p:cNvPr id="78" name="Rectangle 77"/>
           <p:cNvSpPr/>
           <p:nvPr/>
         </p:nvSpPr>
@@ -6623,7 +6158,7 @@
       </p:sp>
       <p:sp>
         <p:nvSpPr>
-          <p:cNvPr id="91" name="TextBox 90"/>
+          <p:cNvPr id="79" name="TextBox 78"/>
           <p:cNvSpPr txBox="1"/>
           <p:nvPr/>
         </p:nvSpPr>
@@ -6658,7 +6193,7 @@
       </p:sp>
       <p:sp>
         <p:nvSpPr>
-          <p:cNvPr id="92" name="Rectangle 91"/>
+          <p:cNvPr id="80" name="Rectangle 79"/>
           <p:cNvSpPr/>
           <p:nvPr/>
         </p:nvSpPr>
@@ -6702,7 +6237,7 @@
       </p:sp>
       <p:sp>
         <p:nvSpPr>
-          <p:cNvPr id="93" name="TextBox 92"/>
+          <p:cNvPr id="81" name="TextBox 80"/>
           <p:cNvSpPr txBox="1"/>
           <p:nvPr/>
         </p:nvSpPr>
@@ -6737,7 +6272,7 @@
       </p:sp>
       <p:sp>
         <p:nvSpPr>
-          <p:cNvPr id="94" name="Rectangle 93"/>
+          <p:cNvPr id="82" name="Rectangle 81"/>
           <p:cNvSpPr/>
           <p:nvPr/>
         </p:nvSpPr>
@@ -6781,7 +6316,7 @@
       </p:sp>
       <p:sp>
         <p:nvSpPr>
-          <p:cNvPr id="95" name="TextBox 94"/>
+          <p:cNvPr id="83" name="TextBox 82"/>
           <p:cNvSpPr txBox="1"/>
           <p:nvPr/>
         </p:nvSpPr>
@@ -6816,7 +6351,7 @@
       </p:sp>
       <p:sp>
         <p:nvSpPr>
-          <p:cNvPr id="96" name="Rectangle 95"/>
+          <p:cNvPr id="84" name="Rectangle 83"/>
           <p:cNvSpPr/>
           <p:nvPr/>
         </p:nvSpPr>
@@ -6860,7 +6395,7 @@
       </p:sp>
       <p:sp>
         <p:nvSpPr>
-          <p:cNvPr id="97" name="Rectangle 96"/>
+          <p:cNvPr id="85" name="Rectangle 84"/>
           <p:cNvSpPr/>
           <p:nvPr/>
         </p:nvSpPr>
@@ -6904,7 +6439,7 @@
       </p:sp>
       <p:sp>
         <p:nvSpPr>
-          <p:cNvPr id="98" name="Rectangle 97"/>
+          <p:cNvPr id="86" name="Rectangle 85"/>
           <p:cNvSpPr/>
           <p:nvPr/>
         </p:nvSpPr>
@@ -6948,7 +6483,7 @@
       </p:sp>
       <p:sp>
         <p:nvSpPr>
-          <p:cNvPr id="99" name="TextBox 98"/>
+          <p:cNvPr id="87" name="TextBox 86"/>
           <p:cNvSpPr txBox="1"/>
           <p:nvPr/>
         </p:nvSpPr>
@@ -6983,7 +6518,7 @@
       </p:sp>
       <p:sp>
         <p:nvSpPr>
-          <p:cNvPr id="100" name="Rectangle 99"/>
+          <p:cNvPr id="88" name="Rectangle 87"/>
           <p:cNvSpPr/>
           <p:nvPr/>
         </p:nvSpPr>
@@ -7027,7 +6562,7 @@
       </p:sp>
       <p:sp>
         <p:nvSpPr>
-          <p:cNvPr id="101" name="Rectangle 100"/>
+          <p:cNvPr id="89" name="Rectangle 88"/>
           <p:cNvSpPr/>
           <p:nvPr/>
         </p:nvSpPr>
@@ -7071,7 +6606,7 @@
       </p:sp>
       <p:sp>
         <p:nvSpPr>
-          <p:cNvPr id="102" name="TextBox 101"/>
+          <p:cNvPr id="90" name="TextBox 89"/>
           <p:cNvSpPr txBox="1"/>
           <p:nvPr/>
         </p:nvSpPr>
@@ -7106,7 +6641,7 @@
       </p:sp>
       <p:sp>
         <p:nvSpPr>
-          <p:cNvPr id="103" name="Rectangle 102"/>
+          <p:cNvPr id="91" name="Rectangle 90"/>
           <p:cNvSpPr/>
           <p:nvPr/>
         </p:nvSpPr>
@@ -7150,7 +6685,7 @@
       </p:sp>
       <p:sp>
         <p:nvSpPr>
-          <p:cNvPr id="104" name="Rectangle 103"/>
+          <p:cNvPr id="92" name="Rectangle 91"/>
           <p:cNvSpPr/>
           <p:nvPr/>
         </p:nvSpPr>
@@ -7194,7 +6729,7 @@
       </p:sp>
       <p:sp>
         <p:nvSpPr>
-          <p:cNvPr id="105" name="Rectangle 104"/>
+          <p:cNvPr id="93" name="Rectangle 92"/>
           <p:cNvSpPr/>
           <p:nvPr/>
         </p:nvSpPr>
@@ -7637,7 +7172,7 @@
                 </a:solidFill>
                 <a:latin typeface="Arial"/>
               </a:rPr>
-              <a:t>Le forfait 40 Go est le plus efficace</a:t>
+              <a:t>Les forfaits 40 Go et 150 Go font jeu égal</a:t>
             </a:r>
           </a:p>
         </p:txBody>
@@ -7672,7 +7207,7 @@
                 </a:solidFill>
                 <a:latin typeface="Arial"/>
               </a:rPr>
-              <a:t>Le forfait 40 Go sans engagement concentre deux tiers de la diffusion et reste au niveau du meilleur CTR (1,02 fois la moyenne).</a:t>
+              <a:t>Le forfait 40 Go (deux tiers de la diffusion) et le forfait 150 Go obtiennent le même CTR (0,99 à 1,02 fois la moyenne).</a:t>
             </a:r>
           </a:p>
         </p:txBody>
@@ -7707,7 +7242,7 @@
                 </a:solidFill>
                 <a:latin typeface="Arial"/>
               </a:rPr>
-              <a:t>→  Garder le 40 Go comme offre d'appel.</a:t>
+              <a:t>→  Garder le 40 Go comme offre d'appel, au prix le plus bas.</a:t>
             </a:r>
           </a:p>
         </p:txBody>

</xml_diff>

<commit_message>
Cdiscount Mobile : slide 1 sur le modèle d'août
Co-Authored-By: Claude Opus 5.5 <noreply@anthropic.com>
Claude-Session: https://claude.ai/code/session_01BmxtdWjbeRUyPx9e1qVLbT
</commit_message>
<xml_diff>
--- a/rapports/septembre/Cdiscount_Mobile_sept2026.pptx
+++ b/rapports/septembre/Cdiscount_Mobile_sept2026.pptx
@@ -5291,15 +5291,6 @@
               </a:rPr>
               <a:t>forfait mobile</a:t>
             </a:r>
-            <a:r>
-              <a:rPr sz="1800" b="1" i="0">
-                <a:solidFill>
-                  <a:srgbClr val="111111"/>
-                </a:solidFill>
-                <a:latin typeface="Arial"/>
-              </a:rPr>
-              <a:t>   sans engagement</a:t>
-            </a:r>
           </a:p>
           <a:p>
             <a:pPr algn="l">
@@ -5308,22 +5299,22 @@
               </a:spcAft>
             </a:pPr>
             <a:r>
-              <a:rPr sz="1600" b="1" i="0">
+              <a:rPr sz="1700" b="1" i="0">
+                <a:solidFill>
+                  <a:srgbClr val="111111"/>
+                </a:solidFill>
+                <a:latin typeface="Arial"/>
+              </a:rPr>
+              <a:t>sans engagement</a:t>
+            </a:r>
+            <a:r>
+              <a:rPr sz="1500" b="0" i="0">
                 <a:solidFill>
                   <a:srgbClr val="555B66"/>
                 </a:solidFill>
                 <a:latin typeface="Arial"/>
               </a:rPr>
-              <a:t>40 Go</a:t>
-            </a:r>
-            <a:r>
-              <a:rPr sz="1500" b="1" i="0">
-                <a:solidFill>
-                  <a:srgbClr val="111111"/>
-                </a:solidFill>
-                <a:latin typeface="Arial"/>
-              </a:rPr>
-              <a:t>   150 Go</a:t>
+              <a:t>      eSIM</a:t>
             </a:r>
           </a:p>
           <a:p>
@@ -5333,22 +5324,31 @@
               </a:spcAft>
             </a:pPr>
             <a:r>
+              <a:rPr sz="1400" b="1" i="0">
+                <a:solidFill>
+                  <a:srgbClr val="EE6A2C"/>
+                </a:solidFill>
+                <a:latin typeface="Arial"/>
+              </a:rPr>
+              <a:t>40 Go</a:t>
+            </a:r>
+            <a:r>
               <a:rPr sz="1300" b="1" i="0">
                 <a:solidFill>
-                  <a:srgbClr val="EE6A2C"/>
-                </a:solidFill>
-                <a:latin typeface="Arial"/>
-              </a:rPr>
-              <a:t>4G &amp; 5G</a:t>
-            </a:r>
-            <a:r>
-              <a:rPr sz="1200" b="0" i="0">
+                  <a:srgbClr val="111111"/>
+                </a:solidFill>
+                <a:latin typeface="Arial"/>
+              </a:rPr>
+              <a:t>   150 Go</a:t>
+            </a:r>
+            <a:r>
+              <a:rPr sz="1300" b="0" i="0">
                 <a:solidFill>
                   <a:srgbClr val="555B66"/>
                 </a:solidFill>
                 <a:latin typeface="Arial"/>
               </a:rPr>
-              <a:t>   eSIM</a:t>
+              <a:t>   5G</a:t>
             </a:r>
           </a:p>
           <a:p>
@@ -5364,7 +5364,7 @@
                 </a:solidFill>
                 <a:latin typeface="Arial"/>
               </a:rPr>
-              <a:t>meilleur prix</a:t>
+              <a:t>carte SIM</a:t>
             </a:r>
             <a:r>
               <a:rPr sz="1100" b="1" i="0">
@@ -5373,7 +5373,16 @@
                 </a:solidFill>
                 <a:latin typeface="Arial"/>
               </a:rPr>
-              <a:t>   data</a:t>
+              <a:t>   code RIO</a:t>
+            </a:r>
+            <a:r>
+              <a:rPr sz="1100" b="0" i="0">
+                <a:solidFill>
+                  <a:srgbClr val="555B66"/>
+                </a:solidFill>
+                <a:latin typeface="Arial"/>
+              </a:rPr>
+              <a:t>   portabilité</a:t>
             </a:r>
           </a:p>
           <a:p>
@@ -5385,20 +5394,20 @@
             <a:r>
               <a:rPr sz="1100" b="1" i="0">
                 <a:solidFill>
+                  <a:srgbClr val="EE6A2C"/>
+                </a:solidFill>
+                <a:latin typeface="Arial"/>
+              </a:rPr>
+              <a:t>activation immédiate</a:t>
+            </a:r>
+            <a:r>
+              <a:rPr sz="1100" b="1" i="0">
+                <a:solidFill>
                   <a:srgbClr val="111111"/>
                 </a:solidFill>
                 <a:latin typeface="Arial"/>
               </a:rPr>
-              <a:t>départ en vacances</a:t>
-            </a:r>
-            <a:r>
-              <a:rPr sz="1100" b="0" i="0">
-                <a:solidFill>
-                  <a:srgbClr val="555B66"/>
-                </a:solidFill>
-                <a:latin typeface="Arial"/>
-              </a:rPr>
-              <a:t>   changement d'opérateur</a:t>
+              <a:t>   partage de connexion</a:t>
             </a:r>
           </a:p>
           <a:p>
@@ -5414,7 +5423,7 @@
                 </a:solidFill>
                 <a:latin typeface="Arial"/>
               </a:rPr>
-              <a:t>promotion</a:t>
+              <a:t>roaming</a:t>
             </a:r>
             <a:r>
               <a:rPr sz="1100" b="0" i="0">
@@ -5423,7 +5432,16 @@
                 </a:solidFill>
                 <a:latin typeface="Arial"/>
               </a:rPr>
-              <a:t>   compatibilité</a:t>
+              <a:t>   meilleur prix</a:t>
+            </a:r>
+            <a:r>
+              <a:rPr sz="1100" b="1" i="0">
+                <a:solidFill>
+                  <a:srgbClr val="EE6A2C"/>
+                </a:solidFill>
+                <a:latin typeface="Arial"/>
+              </a:rPr>
+              <a:t>   départ en vacances</a:t>
             </a:r>
           </a:p>
         </p:txBody>
@@ -5607,14 +5625,470 @@
                 </a:solidFill>
                 <a:latin typeface="Arial"/>
               </a:rPr>
-              <a:t>À compléter : le rapport d'insights porte surtout sur les smartphones, pas sur les forfaits</a:t>
-            </a:r>
-          </a:p>
-        </p:txBody>
-      </p:sp>
-      <p:sp>
-        <p:nvSpPr>
-          <p:cNvPr id="65" name="TextBox 64"/>
+              <a:t>Quel forfait mobile sans engagement choisir ?</a:t>
+            </a:r>
+          </a:p>
+        </p:txBody>
+      </p:sp>
+      <p:sp>
+        <p:nvSpPr>
+          <p:cNvPr id="65" name="Rectangle 64"/>
+          <p:cNvSpPr/>
+          <p:nvPr/>
+        </p:nvSpPr>
+        <p:spPr>
+          <a:xfrm>
+            <a:off x="4437888" y="4632960"/>
+            <a:ext cx="2913888" cy="304800"/>
+          </a:xfrm>
+          <a:prstGeom prst="rect">
+            <a:avLst/>
+          </a:prstGeom>
+          <a:solidFill>
+            <a:srgbClr val="F1EFEA"/>
+          </a:solidFill>
+          <a:ln>
+            <a:noFill/>
+          </a:ln>
+          <a:effectLst/>
+        </p:spPr>
+        <p:style>
+          <a:lnRef idx="1">
+            <a:schemeClr val="accent1"/>
+          </a:lnRef>
+          <a:fillRef idx="3">
+            <a:schemeClr val="accent1"/>
+          </a:fillRef>
+          <a:effectRef idx="2">
+            <a:schemeClr val="accent1"/>
+          </a:effectRef>
+          <a:fontRef idx="minor">
+            <a:schemeClr val="lt1"/>
+          </a:fontRef>
+        </p:style>
+        <p:txBody>
+          <a:bodyPr rtlCol="0" anchor="ctr"/>
+          <a:lstStyle/>
+          <a:p>
+            <a:pPr algn="ctr"/>
+          </a:p>
+        </p:txBody>
+      </p:sp>
+      <p:sp>
+        <p:nvSpPr>
+          <p:cNvPr id="66" name="TextBox 65"/>
+          <p:cNvSpPr txBox="1"/>
+          <p:nvPr/>
+        </p:nvSpPr>
+        <p:spPr>
+          <a:xfrm>
+            <a:off x="4559808" y="4632960"/>
+            <a:ext cx="182880" cy="304800"/>
+          </a:xfrm>
+          <a:prstGeom prst="rect">
+            <a:avLst/>
+          </a:prstGeom>
+          <a:noFill/>
+        </p:spPr>
+        <p:txBody>
+          <a:bodyPr wrap="square" anchor="ctr" lIns="0" rIns="0" tIns="0" bIns="0">
+            <a:spAutoFit/>
+          </a:bodyPr>
+          <a:lstStyle/>
+          <a:p>
+            <a:pPr algn="l"/>
+            <a:r>
+              <a:rPr sz="900" b="0" i="0">
+                <a:solidFill>
+                  <a:srgbClr val="555B66"/>
+                </a:solidFill>
+                <a:latin typeface="Arial"/>
+              </a:rPr>
+              <a:t>🔍</a:t>
+            </a:r>
+          </a:p>
+        </p:txBody>
+      </p:sp>
+      <p:sp>
+        <p:nvSpPr>
+          <p:cNvPr id="67" name="TextBox 66"/>
+          <p:cNvSpPr txBox="1"/>
+          <p:nvPr/>
+        </p:nvSpPr>
+        <p:spPr>
+          <a:xfrm>
+            <a:off x="4791456" y="4632960"/>
+            <a:ext cx="2499360" cy="304800"/>
+          </a:xfrm>
+          <a:prstGeom prst="rect">
+            <a:avLst/>
+          </a:prstGeom>
+          <a:noFill/>
+        </p:spPr>
+        <p:txBody>
+          <a:bodyPr wrap="square" anchor="ctr" lIns="0" rIns="0" tIns="0" bIns="0">
+            <a:spAutoFit/>
+          </a:bodyPr>
+          <a:lstStyle/>
+          <a:p>
+            <a:pPr algn="l"/>
+            <a:r>
+              <a:rPr sz="900" b="0" i="0">
+                <a:solidFill>
+                  <a:srgbClr val="111111"/>
+                </a:solidFill>
+                <a:latin typeface="Arial"/>
+              </a:rPr>
+              <a:t>Puis-je utiliser une eSIM avec Cdiscount Mobile ?</a:t>
+            </a:r>
+          </a:p>
+        </p:txBody>
+      </p:sp>
+      <p:sp>
+        <p:nvSpPr>
+          <p:cNvPr id="68" name="Rectangle 67"/>
+          <p:cNvSpPr/>
+          <p:nvPr/>
+        </p:nvSpPr>
+        <p:spPr>
+          <a:xfrm>
+            <a:off x="4437888" y="4998720"/>
+            <a:ext cx="2913888" cy="304800"/>
+          </a:xfrm>
+          <a:prstGeom prst="rect">
+            <a:avLst/>
+          </a:prstGeom>
+          <a:solidFill>
+            <a:srgbClr val="F1EFEA"/>
+          </a:solidFill>
+          <a:ln>
+            <a:noFill/>
+          </a:ln>
+          <a:effectLst/>
+        </p:spPr>
+        <p:style>
+          <a:lnRef idx="1">
+            <a:schemeClr val="accent1"/>
+          </a:lnRef>
+          <a:fillRef idx="3">
+            <a:schemeClr val="accent1"/>
+          </a:fillRef>
+          <a:effectRef idx="2">
+            <a:schemeClr val="accent1"/>
+          </a:effectRef>
+          <a:fontRef idx="minor">
+            <a:schemeClr val="lt1"/>
+          </a:fontRef>
+        </p:style>
+        <p:txBody>
+          <a:bodyPr rtlCol="0" anchor="ctr"/>
+          <a:lstStyle/>
+          <a:p>
+            <a:pPr algn="ctr"/>
+          </a:p>
+        </p:txBody>
+      </p:sp>
+      <p:sp>
+        <p:nvSpPr>
+          <p:cNvPr id="69" name="TextBox 68"/>
+          <p:cNvSpPr txBox="1"/>
+          <p:nvPr/>
+        </p:nvSpPr>
+        <p:spPr>
+          <a:xfrm>
+            <a:off x="4559808" y="4998720"/>
+            <a:ext cx="182880" cy="304800"/>
+          </a:xfrm>
+          <a:prstGeom prst="rect">
+            <a:avLst/>
+          </a:prstGeom>
+          <a:noFill/>
+        </p:spPr>
+        <p:txBody>
+          <a:bodyPr wrap="square" anchor="ctr" lIns="0" rIns="0" tIns="0" bIns="0">
+            <a:spAutoFit/>
+          </a:bodyPr>
+          <a:lstStyle/>
+          <a:p>
+            <a:pPr algn="l"/>
+            <a:r>
+              <a:rPr sz="900" b="0" i="0">
+                <a:solidFill>
+                  <a:srgbClr val="555B66"/>
+                </a:solidFill>
+                <a:latin typeface="Arial"/>
+              </a:rPr>
+              <a:t>🔍</a:t>
+            </a:r>
+          </a:p>
+        </p:txBody>
+      </p:sp>
+      <p:sp>
+        <p:nvSpPr>
+          <p:cNvPr id="70" name="TextBox 69"/>
+          <p:cNvSpPr txBox="1"/>
+          <p:nvPr/>
+        </p:nvSpPr>
+        <p:spPr>
+          <a:xfrm>
+            <a:off x="4791456" y="4998720"/>
+            <a:ext cx="2499360" cy="304800"/>
+          </a:xfrm>
+          <a:prstGeom prst="rect">
+            <a:avLst/>
+          </a:prstGeom>
+          <a:noFill/>
+        </p:spPr>
+        <p:txBody>
+          <a:bodyPr wrap="square" anchor="ctr" lIns="0" rIns="0" tIns="0" bIns="0">
+            <a:spAutoFit/>
+          </a:bodyPr>
+          <a:lstStyle/>
+          <a:p>
+            <a:pPr algn="l"/>
+            <a:r>
+              <a:rPr sz="900" b="0" i="0">
+                <a:solidFill>
+                  <a:srgbClr val="111111"/>
+                </a:solidFill>
+                <a:latin typeface="Arial"/>
+              </a:rPr>
+              <a:t>Puis-je conserver mon numéro en changeant d'opérateur ?</a:t>
+            </a:r>
+          </a:p>
+        </p:txBody>
+      </p:sp>
+      <p:sp>
+        <p:nvSpPr>
+          <p:cNvPr id="71" name="Rectangle 70"/>
+          <p:cNvSpPr/>
+          <p:nvPr/>
+        </p:nvSpPr>
+        <p:spPr>
+          <a:xfrm>
+            <a:off x="4437888" y="5364480"/>
+            <a:ext cx="2913888" cy="304800"/>
+          </a:xfrm>
+          <a:prstGeom prst="rect">
+            <a:avLst/>
+          </a:prstGeom>
+          <a:solidFill>
+            <a:srgbClr val="F1EFEA"/>
+          </a:solidFill>
+          <a:ln>
+            <a:noFill/>
+          </a:ln>
+          <a:effectLst/>
+        </p:spPr>
+        <p:style>
+          <a:lnRef idx="1">
+            <a:schemeClr val="accent1"/>
+          </a:lnRef>
+          <a:fillRef idx="3">
+            <a:schemeClr val="accent1"/>
+          </a:fillRef>
+          <a:effectRef idx="2">
+            <a:schemeClr val="accent1"/>
+          </a:effectRef>
+          <a:fontRef idx="minor">
+            <a:schemeClr val="lt1"/>
+          </a:fontRef>
+        </p:style>
+        <p:txBody>
+          <a:bodyPr rtlCol="0" anchor="ctr"/>
+          <a:lstStyle/>
+          <a:p>
+            <a:pPr algn="ctr"/>
+          </a:p>
+        </p:txBody>
+      </p:sp>
+      <p:sp>
+        <p:nvSpPr>
+          <p:cNvPr id="72" name="TextBox 71"/>
+          <p:cNvSpPr txBox="1"/>
+          <p:nvPr/>
+        </p:nvSpPr>
+        <p:spPr>
+          <a:xfrm>
+            <a:off x="4559808" y="5364480"/>
+            <a:ext cx="182880" cy="304800"/>
+          </a:xfrm>
+          <a:prstGeom prst="rect">
+            <a:avLst/>
+          </a:prstGeom>
+          <a:noFill/>
+        </p:spPr>
+        <p:txBody>
+          <a:bodyPr wrap="square" anchor="ctr" lIns="0" rIns="0" tIns="0" bIns="0">
+            <a:spAutoFit/>
+          </a:bodyPr>
+          <a:lstStyle/>
+          <a:p>
+            <a:pPr algn="l"/>
+            <a:r>
+              <a:rPr sz="900" b="0" i="0">
+                <a:solidFill>
+                  <a:srgbClr val="555B66"/>
+                </a:solidFill>
+                <a:latin typeface="Arial"/>
+              </a:rPr>
+              <a:t>🔍</a:t>
+            </a:r>
+          </a:p>
+        </p:txBody>
+      </p:sp>
+      <p:sp>
+        <p:nvSpPr>
+          <p:cNvPr id="73" name="TextBox 72"/>
+          <p:cNvSpPr txBox="1"/>
+          <p:nvPr/>
+        </p:nvSpPr>
+        <p:spPr>
+          <a:xfrm>
+            <a:off x="4791456" y="5364480"/>
+            <a:ext cx="2499360" cy="304800"/>
+          </a:xfrm>
+          <a:prstGeom prst="rect">
+            <a:avLst/>
+          </a:prstGeom>
+          <a:noFill/>
+        </p:spPr>
+        <p:txBody>
+          <a:bodyPr wrap="square" anchor="ctr" lIns="0" rIns="0" tIns="0" bIns="0">
+            <a:spAutoFit/>
+          </a:bodyPr>
+          <a:lstStyle/>
+          <a:p>
+            <a:pPr algn="l"/>
+            <a:r>
+              <a:rPr sz="900" b="0" i="0">
+                <a:solidFill>
+                  <a:srgbClr val="111111"/>
+                </a:solidFill>
+                <a:latin typeface="Arial"/>
+              </a:rPr>
+              <a:t>Quel forfait pour faire du partage de connexion ?</a:t>
+            </a:r>
+          </a:p>
+        </p:txBody>
+      </p:sp>
+      <p:sp>
+        <p:nvSpPr>
+          <p:cNvPr id="74" name="Rectangle 73"/>
+          <p:cNvSpPr/>
+          <p:nvPr/>
+        </p:nvSpPr>
+        <p:spPr>
+          <a:xfrm>
+            <a:off x="4437888" y="5730240"/>
+            <a:ext cx="2913888" cy="304800"/>
+          </a:xfrm>
+          <a:prstGeom prst="rect">
+            <a:avLst/>
+          </a:prstGeom>
+          <a:solidFill>
+            <a:srgbClr val="F1EFEA"/>
+          </a:solidFill>
+          <a:ln>
+            <a:noFill/>
+          </a:ln>
+          <a:effectLst/>
+        </p:spPr>
+        <p:style>
+          <a:lnRef idx="1">
+            <a:schemeClr val="accent1"/>
+          </a:lnRef>
+          <a:fillRef idx="3">
+            <a:schemeClr val="accent1"/>
+          </a:fillRef>
+          <a:effectRef idx="2">
+            <a:schemeClr val="accent1"/>
+          </a:effectRef>
+          <a:fontRef idx="minor">
+            <a:schemeClr val="lt1"/>
+          </a:fontRef>
+        </p:style>
+        <p:txBody>
+          <a:bodyPr rtlCol="0" anchor="ctr"/>
+          <a:lstStyle/>
+          <a:p>
+            <a:pPr algn="ctr"/>
+          </a:p>
+        </p:txBody>
+      </p:sp>
+      <p:sp>
+        <p:nvSpPr>
+          <p:cNvPr id="75" name="TextBox 74"/>
+          <p:cNvSpPr txBox="1"/>
+          <p:nvPr/>
+        </p:nvSpPr>
+        <p:spPr>
+          <a:xfrm>
+            <a:off x="4559808" y="5730240"/>
+            <a:ext cx="182880" cy="304800"/>
+          </a:xfrm>
+          <a:prstGeom prst="rect">
+            <a:avLst/>
+          </a:prstGeom>
+          <a:noFill/>
+        </p:spPr>
+        <p:txBody>
+          <a:bodyPr wrap="square" anchor="ctr" lIns="0" rIns="0" tIns="0" bIns="0">
+            <a:spAutoFit/>
+          </a:bodyPr>
+          <a:lstStyle/>
+          <a:p>
+            <a:pPr algn="l"/>
+            <a:r>
+              <a:rPr sz="900" b="0" i="0">
+                <a:solidFill>
+                  <a:srgbClr val="555B66"/>
+                </a:solidFill>
+                <a:latin typeface="Arial"/>
+              </a:rPr>
+              <a:t>🔍</a:t>
+            </a:r>
+          </a:p>
+        </p:txBody>
+      </p:sp>
+      <p:sp>
+        <p:nvSpPr>
+          <p:cNvPr id="76" name="TextBox 75"/>
+          <p:cNvSpPr txBox="1"/>
+          <p:nvPr/>
+        </p:nvSpPr>
+        <p:spPr>
+          <a:xfrm>
+            <a:off x="4791456" y="5730240"/>
+            <a:ext cx="2499360" cy="304800"/>
+          </a:xfrm>
+          <a:prstGeom prst="rect">
+            <a:avLst/>
+          </a:prstGeom>
+          <a:noFill/>
+        </p:spPr>
+        <p:txBody>
+          <a:bodyPr wrap="square" anchor="ctr" lIns="0" rIns="0" tIns="0" bIns="0">
+            <a:spAutoFit/>
+          </a:bodyPr>
+          <a:lstStyle/>
+          <a:p>
+            <a:pPr algn="l"/>
+            <a:r>
+              <a:rPr sz="900" b="0" i="0">
+                <a:solidFill>
+                  <a:srgbClr val="111111"/>
+                </a:solidFill>
+                <a:latin typeface="Arial"/>
+              </a:rPr>
+              <a:t>Quel forfait prendre pour partir en vacances à l'étranger ?</a:t>
+            </a:r>
+          </a:p>
+        </p:txBody>
+      </p:sp>
+      <p:sp>
+        <p:nvSpPr>
+          <p:cNvPr id="77" name="TextBox 76"/>
           <p:cNvSpPr txBox="1"/>
           <p:nvPr/>
         </p:nvSpPr>
@@ -5649,7 +6123,7 @@
       </p:sp>
       <p:sp>
         <p:nvSpPr>
-          <p:cNvPr id="66" name="TextBox 65"/>
+          <p:cNvPr id="78" name="TextBox 77"/>
           <p:cNvSpPr txBox="1"/>
           <p:nvPr/>
         </p:nvSpPr>
@@ -5684,7 +6158,7 @@
       </p:sp>
       <p:sp>
         <p:nvSpPr>
-          <p:cNvPr id="67" name="TextBox 66"/>
+          <p:cNvPr id="79" name="TextBox 78"/>
           <p:cNvSpPr txBox="1"/>
           <p:nvPr/>
         </p:nvSpPr>
@@ -5719,7 +6193,7 @@
       </p:sp>
       <p:sp>
         <p:nvSpPr>
-          <p:cNvPr id="68" name="Rectangle 67"/>
+          <p:cNvPr id="80" name="Rectangle 79"/>
           <p:cNvSpPr/>
           <p:nvPr/>
         </p:nvSpPr>
@@ -5763,7 +6237,7 @@
       </p:sp>
       <p:sp>
         <p:nvSpPr>
-          <p:cNvPr id="69" name="TextBox 68"/>
+          <p:cNvPr id="81" name="TextBox 80"/>
           <p:cNvSpPr txBox="1"/>
           <p:nvPr/>
         </p:nvSpPr>
@@ -5785,20 +6259,20 @@
           <a:p>
             <a:pPr algn="l"/>
             <a:r>
-              <a:rPr sz="800" b="0" i="0">
+              <a:rPr sz="1000" b="0" i="0">
                 <a:solidFill>
                   <a:srgbClr val="111111"/>
                 </a:solidFill>
                 <a:latin typeface="Arial"/>
               </a:rPr>
-              <a:t>Recherche générale d'un forfait · &lt; 1 %</a:t>
-            </a:r>
-          </a:p>
-        </p:txBody>
-      </p:sp>
-      <p:sp>
-        <p:nvSpPr>
-          <p:cNvPr id="70" name="Rectangle 69"/>
+              <a:t>Recherche générale d'un forfait</a:t>
+            </a:r>
+          </a:p>
+        </p:txBody>
+      </p:sp>
+      <p:sp>
+        <p:nvSpPr>
+          <p:cNvPr id="82" name="Rectangle 81"/>
           <p:cNvSpPr/>
           <p:nvPr/>
         </p:nvSpPr>
@@ -5842,7 +6316,7 @@
       </p:sp>
       <p:sp>
         <p:nvSpPr>
-          <p:cNvPr id="71" name="TextBox 70"/>
+          <p:cNvPr id="83" name="TextBox 82"/>
           <p:cNvSpPr txBox="1"/>
           <p:nvPr/>
         </p:nvSpPr>
@@ -5870,14 +6344,14 @@
                 </a:solidFill>
                 <a:latin typeface="Arial"/>
               </a:rPr>
-              <a:t>eSIM et carte SIM · &lt; 1 %</a:t>
-            </a:r>
-          </a:p>
-        </p:txBody>
-      </p:sp>
-      <p:sp>
-        <p:nvSpPr>
-          <p:cNvPr id="72" name="Rectangle 71"/>
+              <a:t>eSIM et carte SIM · 25 %</a:t>
+            </a:r>
+          </a:p>
+        </p:txBody>
+      </p:sp>
+      <p:sp>
+        <p:nvSpPr>
+          <p:cNvPr id="84" name="Rectangle 83"/>
           <p:cNvSpPr/>
           <p:nvPr/>
         </p:nvSpPr>
@@ -5921,7 +6395,7 @@
       </p:sp>
       <p:sp>
         <p:nvSpPr>
-          <p:cNvPr id="73" name="TextBox 72"/>
+          <p:cNvPr id="85" name="TextBox 84"/>
           <p:cNvSpPr txBox="1"/>
           <p:nvPr/>
         </p:nvSpPr>
@@ -5949,14 +6423,14 @@
                 </a:solidFill>
                 <a:latin typeface="Arial"/>
               </a:rPr>
-              <a:t>Prix et sans engagement · 66 %</a:t>
-            </a:r>
-          </a:p>
-        </p:txBody>
-      </p:sp>
-      <p:sp>
-        <p:nvSpPr>
-          <p:cNvPr id="74" name="Rectangle 73"/>
+              <a:t>Prix et sans engagement · 15 %</a:t>
+            </a:r>
+          </a:p>
+        </p:txBody>
+      </p:sp>
+      <p:sp>
+        <p:nvSpPr>
+          <p:cNvPr id="86" name="Rectangle 85"/>
           <p:cNvSpPr/>
           <p:nvPr/>
         </p:nvSpPr>
@@ -6000,7 +6474,7 @@
       </p:sp>
       <p:sp>
         <p:nvSpPr>
-          <p:cNvPr id="75" name="TextBox 74"/>
+          <p:cNvPr id="87" name="TextBox 86"/>
           <p:cNvSpPr txBox="1"/>
           <p:nvPr/>
         </p:nvSpPr>
@@ -6028,14 +6502,14 @@
                 </a:solidFill>
                 <a:latin typeface="Arial"/>
               </a:rPr>
-              <a:t>Partage de connexion et nomade · &lt; 1 %</a:t>
-            </a:r>
-          </a:p>
-        </p:txBody>
-      </p:sp>
-      <p:sp>
-        <p:nvSpPr>
-          <p:cNvPr id="76" name="Rectangle 75"/>
+              <a:t>Partage de connexion et nomade · 12 %</a:t>
+            </a:r>
+          </a:p>
+        </p:txBody>
+      </p:sp>
+      <p:sp>
+        <p:nvSpPr>
+          <p:cNvPr id="88" name="Rectangle 87"/>
           <p:cNvSpPr/>
           <p:nvPr/>
         </p:nvSpPr>
@@ -6079,7 +6553,7 @@
       </p:sp>
       <p:sp>
         <p:nvSpPr>
-          <p:cNvPr id="77" name="TextBox 76"/>
+          <p:cNvPr id="89" name="TextBox 88"/>
           <p:cNvSpPr txBox="1"/>
           <p:nvPr/>
         </p:nvSpPr>
@@ -6107,14 +6581,14 @@
                 </a:solidFill>
                 <a:latin typeface="Arial"/>
               </a:rPr>
-              <a:t>5G et volume de data · 34 %</a:t>
-            </a:r>
-          </a:p>
-        </p:txBody>
-      </p:sp>
-      <p:sp>
-        <p:nvSpPr>
-          <p:cNvPr id="78" name="Rectangle 77"/>
+              <a:t>5G et volume de data · 6 %</a:t>
+            </a:r>
+          </a:p>
+        </p:txBody>
+      </p:sp>
+      <p:sp>
+        <p:nvSpPr>
+          <p:cNvPr id="90" name="Rectangle 89"/>
           <p:cNvSpPr/>
           <p:nvPr/>
         </p:nvSpPr>
@@ -6158,7 +6632,7 @@
       </p:sp>
       <p:sp>
         <p:nvSpPr>
-          <p:cNvPr id="79" name="TextBox 78"/>
+          <p:cNvPr id="91" name="TextBox 90"/>
           <p:cNvSpPr txBox="1"/>
           <p:nvPr/>
         </p:nvSpPr>
@@ -6186,14 +6660,14 @@
                 </a:solidFill>
                 <a:latin typeface="Arial"/>
               </a:rPr>
-              <a:t>International et roaming · &lt; 1 %</a:t>
-            </a:r>
-          </a:p>
-        </p:txBody>
-      </p:sp>
-      <p:sp>
-        <p:nvSpPr>
-          <p:cNvPr id="80" name="Rectangle 79"/>
+              <a:t>International et roaming · 4 %</a:t>
+            </a:r>
+          </a:p>
+        </p:txBody>
+      </p:sp>
+      <p:sp>
+        <p:nvSpPr>
+          <p:cNvPr id="92" name="Rectangle 91"/>
           <p:cNvSpPr/>
           <p:nvPr/>
         </p:nvSpPr>
@@ -6237,7 +6711,7 @@
       </p:sp>
       <p:sp>
         <p:nvSpPr>
-          <p:cNvPr id="81" name="TextBox 80"/>
+          <p:cNvPr id="93" name="TextBox 92"/>
           <p:cNvSpPr txBox="1"/>
           <p:nvPr/>
         </p:nvSpPr>
@@ -6265,14 +6739,14 @@
                 </a:solidFill>
                 <a:latin typeface="Arial"/>
               </a:rPr>
-              <a:t>Changement d'opérateur · &lt; 1 %</a:t>
-            </a:r>
-          </a:p>
-        </p:txBody>
-      </p:sp>
-      <p:sp>
-        <p:nvSpPr>
-          <p:cNvPr id="82" name="Rectangle 81"/>
+              <a:t>Changement d'opérateur · 1 %</a:t>
+            </a:r>
+          </a:p>
+        </p:txBody>
+      </p:sp>
+      <p:sp>
+        <p:nvSpPr>
+          <p:cNvPr id="94" name="Rectangle 93"/>
           <p:cNvSpPr/>
           <p:nvPr/>
         </p:nvSpPr>
@@ -6316,7 +6790,7 @@
       </p:sp>
       <p:sp>
         <p:nvSpPr>
-          <p:cNvPr id="83" name="TextBox 82"/>
+          <p:cNvPr id="95" name="TextBox 94"/>
           <p:cNvSpPr txBox="1"/>
           <p:nvPr/>
         </p:nvSpPr>
@@ -6344,21 +6818,21 @@
                 </a:solidFill>
                 <a:latin typeface="Arial"/>
               </a:rPr>
-              <a:t>Forfaits par profil · &lt; 1 %</a:t>
-            </a:r>
-          </a:p>
-        </p:txBody>
-      </p:sp>
-      <p:sp>
-        <p:nvSpPr>
-          <p:cNvPr id="84" name="Rectangle 83"/>
+              <a:t>Forfaits par profil · 1 %</a:t>
+            </a:r>
+          </a:p>
+        </p:txBody>
+      </p:sp>
+      <p:sp>
+        <p:nvSpPr>
+          <p:cNvPr id="96" name="Rectangle 95"/>
           <p:cNvSpPr/>
           <p:nvPr/>
         </p:nvSpPr>
         <p:spPr>
           <a:xfrm>
             <a:off x="10564368" y="4450080"/>
-            <a:ext cx="475488" cy="0"/>
+            <a:ext cx="475488" cy="482803"/>
           </a:xfrm>
           <a:prstGeom prst="rect">
             <a:avLst/>
@@ -6395,14 +6869,49 @@
       </p:sp>
       <p:sp>
         <p:nvSpPr>
-          <p:cNvPr id="85" name="Rectangle 84"/>
+          <p:cNvPr id="97" name="TextBox 96"/>
+          <p:cNvSpPr txBox="1"/>
+          <p:nvPr/>
+        </p:nvSpPr>
+        <p:spPr>
+          <a:xfrm>
+            <a:off x="10564368" y="4450080"/>
+            <a:ext cx="475488" cy="482803"/>
+          </a:xfrm>
+          <a:prstGeom prst="rect">
+            <a:avLst/>
+          </a:prstGeom>
+          <a:noFill/>
+        </p:spPr>
+        <p:txBody>
+          <a:bodyPr wrap="square" anchor="ctr" lIns="0" rIns="0" tIns="0" bIns="0">
+            <a:spAutoFit/>
+          </a:bodyPr>
+          <a:lstStyle/>
+          <a:p>
+            <a:pPr algn="ctr"/>
+            <a:r>
+              <a:rPr sz="1000" b="1" i="0">
+                <a:solidFill>
+                  <a:srgbClr val="FFFFFF"/>
+                </a:solidFill>
+                <a:latin typeface="Arial"/>
+              </a:rPr>
+              <a:t>36 %</a:t>
+            </a:r>
+          </a:p>
+        </p:txBody>
+      </p:sp>
+      <p:sp>
+        <p:nvSpPr>
+          <p:cNvPr id="98" name="Rectangle 97"/>
           <p:cNvSpPr/>
           <p:nvPr/>
         </p:nvSpPr>
         <p:spPr>
           <a:xfrm>
-            <a:off x="10564368" y="4450080"/>
-            <a:ext cx="475488" cy="0"/>
+            <a:off x="10564368" y="4932883"/>
+            <a:ext cx="475488" cy="335280"/>
           </a:xfrm>
           <a:prstGeom prst="rect">
             <a:avLst/>
@@ -6439,14 +6948,49 @@
       </p:sp>
       <p:sp>
         <p:nvSpPr>
-          <p:cNvPr id="86" name="Rectangle 85"/>
+          <p:cNvPr id="99" name="TextBox 98"/>
+          <p:cNvSpPr txBox="1"/>
+          <p:nvPr/>
+        </p:nvSpPr>
+        <p:spPr>
+          <a:xfrm>
+            <a:off x="10564368" y="4932883"/>
+            <a:ext cx="475488" cy="335280"/>
+          </a:xfrm>
+          <a:prstGeom prst="rect">
+            <a:avLst/>
+          </a:prstGeom>
+          <a:noFill/>
+        </p:spPr>
+        <p:txBody>
+          <a:bodyPr wrap="square" anchor="ctr" lIns="0" rIns="0" tIns="0" bIns="0">
+            <a:spAutoFit/>
+          </a:bodyPr>
+          <a:lstStyle/>
+          <a:p>
+            <a:pPr algn="ctr"/>
+            <a:r>
+              <a:rPr sz="1000" b="1" i="0">
+                <a:solidFill>
+                  <a:srgbClr val="FFFFFF"/>
+                </a:solidFill>
+                <a:latin typeface="Arial"/>
+              </a:rPr>
+              <a:t>25 %</a:t>
+            </a:r>
+          </a:p>
+        </p:txBody>
+      </p:sp>
+      <p:sp>
+        <p:nvSpPr>
+          <p:cNvPr id="100" name="Rectangle 99"/>
           <p:cNvSpPr/>
           <p:nvPr/>
         </p:nvSpPr>
         <p:spPr>
           <a:xfrm>
-            <a:off x="10564368" y="4450080"/>
-            <a:ext cx="475488" cy="885139"/>
+            <a:off x="10564368" y="5268163"/>
+            <a:ext cx="475488" cy="201168"/>
           </a:xfrm>
           <a:prstGeom prst="rect">
             <a:avLst/>
@@ -6483,49 +7027,14 @@
       </p:sp>
       <p:sp>
         <p:nvSpPr>
-          <p:cNvPr id="87" name="TextBox 86"/>
-          <p:cNvSpPr txBox="1"/>
-          <p:nvPr/>
-        </p:nvSpPr>
-        <p:spPr>
-          <a:xfrm>
-            <a:off x="10564368" y="4450080"/>
-            <a:ext cx="475488" cy="885139"/>
-          </a:xfrm>
-          <a:prstGeom prst="rect">
-            <a:avLst/>
-          </a:prstGeom>
-          <a:noFill/>
-        </p:spPr>
-        <p:txBody>
-          <a:bodyPr wrap="square" anchor="ctr" lIns="0" rIns="0" tIns="0" bIns="0">
-            <a:spAutoFit/>
-          </a:bodyPr>
-          <a:lstStyle/>
-          <a:p>
-            <a:pPr algn="ctr"/>
-            <a:r>
-              <a:rPr sz="1000" b="1" i="0">
-                <a:solidFill>
-                  <a:srgbClr val="FFFFFF"/>
-                </a:solidFill>
-                <a:latin typeface="Arial"/>
-              </a:rPr>
-              <a:t>66 %</a:t>
-            </a:r>
-          </a:p>
-        </p:txBody>
-      </p:sp>
-      <p:sp>
-        <p:nvSpPr>
-          <p:cNvPr id="88" name="Rectangle 87"/>
+          <p:cNvPr id="101" name="Rectangle 100"/>
           <p:cNvSpPr/>
           <p:nvPr/>
         </p:nvSpPr>
         <p:spPr>
           <a:xfrm>
-            <a:off x="10564368" y="5335219"/>
-            <a:ext cx="475488" cy="0"/>
+            <a:off x="10564368" y="5469331"/>
+            <a:ext cx="475488" cy="160934"/>
           </a:xfrm>
           <a:prstGeom prst="rect">
             <a:avLst/>
@@ -6562,14 +7071,14 @@
       </p:sp>
       <p:sp>
         <p:nvSpPr>
-          <p:cNvPr id="89" name="Rectangle 88"/>
+          <p:cNvPr id="102" name="Rectangle 101"/>
           <p:cNvSpPr/>
           <p:nvPr/>
         </p:nvSpPr>
         <p:spPr>
           <a:xfrm>
-            <a:off x="10564368" y="5335219"/>
-            <a:ext cx="475488" cy="455980"/>
+            <a:off x="10564368" y="5630265"/>
+            <a:ext cx="475488" cy="80467"/>
           </a:xfrm>
           <a:prstGeom prst="rect">
             <a:avLst/>
@@ -6606,49 +7115,14 @@
       </p:sp>
       <p:sp>
         <p:nvSpPr>
-          <p:cNvPr id="90" name="TextBox 89"/>
-          <p:cNvSpPr txBox="1"/>
-          <p:nvPr/>
-        </p:nvSpPr>
-        <p:spPr>
-          <a:xfrm>
-            <a:off x="10564368" y="5335219"/>
-            <a:ext cx="475488" cy="455980"/>
-          </a:xfrm>
-          <a:prstGeom prst="rect">
-            <a:avLst/>
-          </a:prstGeom>
-          <a:noFill/>
-        </p:spPr>
-        <p:txBody>
-          <a:bodyPr wrap="square" anchor="ctr" lIns="0" rIns="0" tIns="0" bIns="0">
-            <a:spAutoFit/>
-          </a:bodyPr>
-          <a:lstStyle/>
-          <a:p>
-            <a:pPr algn="ctr"/>
-            <a:r>
-              <a:rPr sz="1000" b="1" i="0">
-                <a:solidFill>
-                  <a:srgbClr val="FFFFFF"/>
-                </a:solidFill>
-                <a:latin typeface="Arial"/>
-              </a:rPr>
-              <a:t>34 %</a:t>
-            </a:r>
-          </a:p>
-        </p:txBody>
-      </p:sp>
-      <p:sp>
-        <p:nvSpPr>
-          <p:cNvPr id="91" name="Rectangle 90"/>
+          <p:cNvPr id="103" name="Rectangle 102"/>
           <p:cNvSpPr/>
           <p:nvPr/>
         </p:nvSpPr>
         <p:spPr>
           <a:xfrm>
-            <a:off x="10564368" y="5791200"/>
-            <a:ext cx="475488" cy="0"/>
+            <a:off x="10564368" y="5710732"/>
+            <a:ext cx="475488" cy="53644"/>
           </a:xfrm>
           <a:prstGeom prst="rect">
             <a:avLst/>
@@ -6685,14 +7159,14 @@
       </p:sp>
       <p:sp>
         <p:nvSpPr>
-          <p:cNvPr id="92" name="Rectangle 91"/>
+          <p:cNvPr id="104" name="Rectangle 103"/>
           <p:cNvSpPr/>
           <p:nvPr/>
         </p:nvSpPr>
         <p:spPr>
           <a:xfrm>
-            <a:off x="10564368" y="5791200"/>
-            <a:ext cx="475488" cy="0"/>
+            <a:off x="10564368" y="5764377"/>
+            <a:ext cx="475488" cy="13411"/>
           </a:xfrm>
           <a:prstGeom prst="rect">
             <a:avLst/>
@@ -6729,14 +7203,14 @@
       </p:sp>
       <p:sp>
         <p:nvSpPr>
-          <p:cNvPr id="93" name="Rectangle 92"/>
+          <p:cNvPr id="105" name="Rectangle 104"/>
           <p:cNvSpPr/>
           <p:nvPr/>
         </p:nvSpPr>
         <p:spPr>
           <a:xfrm>
-            <a:off x="10564368" y="5791200"/>
-            <a:ext cx="475488" cy="0"/>
+            <a:off x="10564368" y="5777788"/>
+            <a:ext cx="475488" cy="13411"/>
           </a:xfrm>
           <a:prstGeom prst="rect">
             <a:avLst/>

</xml_diff>